<commit_message>
Add references for BLE application
</commit_message>
<xml_diff>
--- a/cablage_robot_pendule.pptx
+++ b/cablage_robot_pendule.pptx
@@ -17,6 +17,7 @@
     <p:sldId id="265" r:id="rId11"/>
     <p:sldId id="266" r:id="rId12"/>
     <p:sldId id="267" r:id="rId13"/>
+    <p:sldId id="268" r:id="rId14"/>
   </p:sldIdLst>
   <p:sldSz cx="12188825" cy="6858000"/>
   <p:notesSz cx="6858000" cy="9144000"/>
@@ -300,7 +301,7 @@
             <a:fld id="{5BCAD085-E8A6-8845-BD4E-CB4CCA059FC4}" type="datetimeFigureOut">
               <a:rPr lang="en-US" smtClean="0"/>
               <a:pPr/>
-              <a:t>5/22/2026</a:t>
+              <a:t>6/17/2026</a:t>
             </a:fld>
             <a:endParaRPr lang="en-US"/>
           </a:p>
@@ -352,7 +353,7 @@
     </p:spTree>
     <p:extLst>
       <p:ext uri="{BB962C8B-B14F-4D97-AF65-F5344CB8AC3E}">
-        <p14:creationId xmlns="" xmlns:p14="http://schemas.microsoft.com/office/powerpoint/2010/main" val="3168075583"/>
+        <p14:creationId xmlns:p14="http://schemas.microsoft.com/office/powerpoint/2010/main" xmlns="" val="3168075583"/>
       </p:ext>
     </p:extLst>
   </p:cSld>
@@ -472,7 +473,7 @@
             <a:fld id="{5BCAD085-E8A6-8845-BD4E-CB4CCA059FC4}" type="datetimeFigureOut">
               <a:rPr lang="en-US" smtClean="0"/>
               <a:pPr/>
-              <a:t>5/22/2026</a:t>
+              <a:t>6/17/2026</a:t>
             </a:fld>
             <a:endParaRPr lang="en-US"/>
           </a:p>
@@ -524,7 +525,7 @@
     </p:spTree>
     <p:extLst>
       <p:ext uri="{BB962C8B-B14F-4D97-AF65-F5344CB8AC3E}">
-        <p14:creationId xmlns="" xmlns:p14="http://schemas.microsoft.com/office/powerpoint/2010/main" val="2910927964"/>
+        <p14:creationId xmlns:p14="http://schemas.microsoft.com/office/powerpoint/2010/main" xmlns="" val="2910927964"/>
       </p:ext>
     </p:extLst>
   </p:cSld>
@@ -654,7 +655,7 @@
             <a:fld id="{5BCAD085-E8A6-8845-BD4E-CB4CCA059FC4}" type="datetimeFigureOut">
               <a:rPr lang="en-US" smtClean="0"/>
               <a:pPr/>
-              <a:t>5/22/2026</a:t>
+              <a:t>6/17/2026</a:t>
             </a:fld>
             <a:endParaRPr lang="en-US"/>
           </a:p>
@@ -706,7 +707,7 @@
     </p:spTree>
     <p:extLst>
       <p:ext uri="{BB962C8B-B14F-4D97-AF65-F5344CB8AC3E}">
-        <p14:creationId xmlns="" xmlns:p14="http://schemas.microsoft.com/office/powerpoint/2010/main" val="3612223792"/>
+        <p14:creationId xmlns:p14="http://schemas.microsoft.com/office/powerpoint/2010/main" xmlns="" val="3612223792"/>
       </p:ext>
     </p:extLst>
   </p:cSld>
@@ -826,7 +827,7 @@
             <a:fld id="{5BCAD085-E8A6-8845-BD4E-CB4CCA059FC4}" type="datetimeFigureOut">
               <a:rPr lang="en-US" smtClean="0"/>
               <a:pPr/>
-              <a:t>5/22/2026</a:t>
+              <a:t>6/17/2026</a:t>
             </a:fld>
             <a:endParaRPr lang="en-US"/>
           </a:p>
@@ -878,7 +879,7 @@
     </p:spTree>
     <p:extLst>
       <p:ext uri="{BB962C8B-B14F-4D97-AF65-F5344CB8AC3E}">
-        <p14:creationId xmlns="" xmlns:p14="http://schemas.microsoft.com/office/powerpoint/2010/main" val="2614314258"/>
+        <p14:creationId xmlns:p14="http://schemas.microsoft.com/office/powerpoint/2010/main" xmlns="" val="2614314258"/>
       </p:ext>
     </p:extLst>
   </p:cSld>
@@ -1074,7 +1075,7 @@
             <a:fld id="{5BCAD085-E8A6-8845-BD4E-CB4CCA059FC4}" type="datetimeFigureOut">
               <a:rPr lang="en-US" smtClean="0"/>
               <a:pPr/>
-              <a:t>5/22/2026</a:t>
+              <a:t>6/17/2026</a:t>
             </a:fld>
             <a:endParaRPr lang="en-US"/>
           </a:p>
@@ -1126,7 +1127,7 @@
     </p:spTree>
     <p:extLst>
       <p:ext uri="{BB962C8B-B14F-4D97-AF65-F5344CB8AC3E}">
-        <p14:creationId xmlns="" xmlns:p14="http://schemas.microsoft.com/office/powerpoint/2010/main" val="960648375"/>
+        <p14:creationId xmlns:p14="http://schemas.microsoft.com/office/powerpoint/2010/main" xmlns="" val="960648375"/>
       </p:ext>
     </p:extLst>
   </p:cSld>
@@ -1364,7 +1365,7 @@
             <a:fld id="{5BCAD085-E8A6-8845-BD4E-CB4CCA059FC4}" type="datetimeFigureOut">
               <a:rPr lang="en-US" smtClean="0"/>
               <a:pPr/>
-              <a:t>5/22/2026</a:t>
+              <a:t>6/17/2026</a:t>
             </a:fld>
             <a:endParaRPr lang="en-US"/>
           </a:p>
@@ -1416,7 +1417,7 @@
     </p:spTree>
     <p:extLst>
       <p:ext uri="{BB962C8B-B14F-4D97-AF65-F5344CB8AC3E}">
-        <p14:creationId xmlns="" xmlns:p14="http://schemas.microsoft.com/office/powerpoint/2010/main" val="2782244947"/>
+        <p14:creationId xmlns:p14="http://schemas.microsoft.com/office/powerpoint/2010/main" xmlns="" val="2782244947"/>
       </p:ext>
     </p:extLst>
   </p:cSld>
@@ -1788,7 +1789,7 @@
             <a:fld id="{5BCAD085-E8A6-8845-BD4E-CB4CCA059FC4}" type="datetimeFigureOut">
               <a:rPr lang="en-US" smtClean="0"/>
               <a:pPr/>
-              <a:t>5/22/2026</a:t>
+              <a:t>6/17/2026</a:t>
             </a:fld>
             <a:endParaRPr lang="en-US"/>
           </a:p>
@@ -1840,7 +1841,7 @@
     </p:spTree>
     <p:extLst>
       <p:ext uri="{BB962C8B-B14F-4D97-AF65-F5344CB8AC3E}">
-        <p14:creationId xmlns="" xmlns:p14="http://schemas.microsoft.com/office/powerpoint/2010/main" val="990158736"/>
+        <p14:creationId xmlns:p14="http://schemas.microsoft.com/office/powerpoint/2010/main" xmlns="" val="990158736"/>
       </p:ext>
     </p:extLst>
   </p:cSld>
@@ -1908,7 +1909,7 @@
             <a:fld id="{5BCAD085-E8A6-8845-BD4E-CB4CCA059FC4}" type="datetimeFigureOut">
               <a:rPr lang="en-US" smtClean="0"/>
               <a:pPr/>
-              <a:t>5/22/2026</a:t>
+              <a:t>6/17/2026</a:t>
             </a:fld>
             <a:endParaRPr lang="en-US"/>
           </a:p>
@@ -1960,7 +1961,7 @@
     </p:spTree>
     <p:extLst>
       <p:ext uri="{BB962C8B-B14F-4D97-AF65-F5344CB8AC3E}">
-        <p14:creationId xmlns="" xmlns:p14="http://schemas.microsoft.com/office/powerpoint/2010/main" val="727027711"/>
+        <p14:creationId xmlns:p14="http://schemas.microsoft.com/office/powerpoint/2010/main" xmlns="" val="727027711"/>
       </p:ext>
     </p:extLst>
   </p:cSld>
@@ -2005,7 +2006,7 @@
             <a:fld id="{5BCAD085-E8A6-8845-BD4E-CB4CCA059FC4}" type="datetimeFigureOut">
               <a:rPr lang="en-US" smtClean="0"/>
               <a:pPr/>
-              <a:t>5/22/2026</a:t>
+              <a:t>6/17/2026</a:t>
             </a:fld>
             <a:endParaRPr lang="en-US"/>
           </a:p>
@@ -2057,7 +2058,7 @@
     </p:spTree>
     <p:extLst>
       <p:ext uri="{BB962C8B-B14F-4D97-AF65-F5344CB8AC3E}">
-        <p14:creationId xmlns="" xmlns:p14="http://schemas.microsoft.com/office/powerpoint/2010/main" val="1212999818"/>
+        <p14:creationId xmlns:p14="http://schemas.microsoft.com/office/powerpoint/2010/main" xmlns="" val="1212999818"/>
       </p:ext>
     </p:extLst>
   </p:cSld>
@@ -2284,7 +2285,7 @@
             <a:fld id="{5BCAD085-E8A6-8845-BD4E-CB4CCA059FC4}" type="datetimeFigureOut">
               <a:rPr lang="en-US" smtClean="0"/>
               <a:pPr/>
-              <a:t>5/22/2026</a:t>
+              <a:t>6/17/2026</a:t>
             </a:fld>
             <a:endParaRPr lang="en-US"/>
           </a:p>
@@ -2336,7 +2337,7 @@
     </p:spTree>
     <p:extLst>
       <p:ext uri="{BB962C8B-B14F-4D97-AF65-F5344CB8AC3E}">
-        <p14:creationId xmlns="" xmlns:p14="http://schemas.microsoft.com/office/powerpoint/2010/main" val="1840726560"/>
+        <p14:creationId xmlns:p14="http://schemas.microsoft.com/office/powerpoint/2010/main" xmlns="" val="1840726560"/>
       </p:ext>
     </p:extLst>
   </p:cSld>
@@ -2539,7 +2540,7 @@
             <a:fld id="{5BCAD085-E8A6-8845-BD4E-CB4CCA059FC4}" type="datetimeFigureOut">
               <a:rPr lang="en-US" smtClean="0"/>
               <a:pPr/>
-              <a:t>5/22/2026</a:t>
+              <a:t>6/17/2026</a:t>
             </a:fld>
             <a:endParaRPr lang="en-US"/>
           </a:p>
@@ -2591,7 +2592,7 @@
     </p:spTree>
     <p:extLst>
       <p:ext uri="{BB962C8B-B14F-4D97-AF65-F5344CB8AC3E}">
-        <p14:creationId xmlns="" xmlns:p14="http://schemas.microsoft.com/office/powerpoint/2010/main" val="3889236939"/>
+        <p14:creationId xmlns:p14="http://schemas.microsoft.com/office/powerpoint/2010/main" xmlns="" val="3889236939"/>
       </p:ext>
     </p:extLst>
   </p:cSld>
@@ -2754,7 +2755,7 @@
             <a:fld id="{5BCAD085-E8A6-8845-BD4E-CB4CCA059FC4}" type="datetimeFigureOut">
               <a:rPr lang="en-US" smtClean="0"/>
               <a:pPr/>
-              <a:t>5/22/2026</a:t>
+              <a:t>6/17/2026</a:t>
             </a:fld>
             <a:endParaRPr lang="en-US"/>
           </a:p>
@@ -2842,7 +2843,7 @@
     </p:spTree>
     <p:extLst>
       <p:ext uri="{BB962C8B-B14F-4D97-AF65-F5344CB8AC3E}">
-        <p14:creationId xmlns="" xmlns:p14="http://schemas.microsoft.com/office/powerpoint/2010/main" val="2209977519"/>
+        <p14:creationId xmlns:p14="http://schemas.microsoft.com/office/powerpoint/2010/main" xmlns="" val="2209977519"/>
       </p:ext>
     </p:extLst>
   </p:cSld>
@@ -22248,6 +22249,64 @@
           </a:p>
         </p:txBody>
       </p:sp>
+    </p:spTree>
+  </p:cSld>
+  <p:clrMapOvr>
+    <a:masterClrMapping/>
+  </p:clrMapOvr>
+</p:sld>
+</file>
+
+<file path=ppt/slides/slide13.xml><?xml version="1.0" encoding="utf-8"?>
+<p:sld xmlns:a="http://schemas.openxmlformats.org/drawingml/2006/main" xmlns:r="http://schemas.openxmlformats.org/officeDocument/2006/relationships" xmlns:p="http://schemas.openxmlformats.org/presentationml/2006/main">
+  <p:cSld>
+    <p:spTree>
+      <p:nvGrpSpPr>
+        <p:cNvPr id="1" name=""/>
+        <p:cNvGrpSpPr/>
+        <p:nvPr/>
+      </p:nvGrpSpPr>
+      <p:grpSpPr>
+        <a:xfrm>
+          <a:off x="0" y="0"/>
+          <a:ext cx="0" cy="0"/>
+          <a:chOff x="0" y="0"/>
+          <a:chExt cx="0" cy="0"/>
+        </a:xfrm>
+      </p:grpSpPr>
+      <p:pic>
+        <p:nvPicPr>
+          <p:cNvPr id="1026" name="Picture 2"/>
+          <p:cNvPicPr>
+            <a:picLocks noChangeAspect="1" noChangeArrowheads="1"/>
+          </p:cNvPicPr>
+          <p:nvPr/>
+        </p:nvPicPr>
+        <p:blipFill>
+          <a:blip r:embed="rId2"/>
+          <a:srcRect/>
+          <a:stretch>
+            <a:fillRect/>
+          </a:stretch>
+        </p:blipFill>
+        <p:spPr bwMode="auto">
+          <a:xfrm>
+            <a:off x="4248150" y="492125"/>
+            <a:ext cx="3695700" cy="5878513"/>
+          </a:xfrm>
+          <a:prstGeom prst="rect">
+            <a:avLst/>
+          </a:prstGeom>
+          <a:noFill/>
+          <a:ln w="9525">
+            <a:noFill/>
+            <a:miter lim="800000"/>
+            <a:headEnd/>
+            <a:tailEnd/>
+          </a:ln>
+          <a:effectLst/>
+        </p:spPr>
+      </p:pic>
     </p:spTree>
   </p:cSld>
   <p:clrMapOvr>

</xml_diff>